<commit_message>
Deck septembre : périmètre final (20 comptes), insights depuis les données ads, sans part de voix, ajout DSR
Co-Authored-By: Claude Opus 5.5 <noreply@anthropic.com>
Claude-Session: https://claude.ai/code/session_01BmxtdWjbeRUyPx9e1qVLbT
</commit_message>
<xml_diff>
--- a/rapports/septembre/Archipel_Kombucha_sept2026.pptx
+++ b/rapports/septembre/Archipel_Kombucha_sept2026.pptx
@@ -7135,7 +7135,7 @@
                 </a:solidFill>
                 <a:latin typeface="Arial"/>
               </a:rPr>
-              <a:t>Rassurer sur la composition et les bienfaits réels</a:t>
+              <a:t>Parler de boissons fermentées sans alcool</a:t>
             </a:r>
           </a:p>
         </p:txBody>
@@ -7170,7 +7170,7 @@
                 </a:solidFill>
                 <a:latin typeface="Arial"/>
               </a:rPr>
-              <a:t>Deux freins seulement ressortent avant l'achat : la composition et les ingrédients (54,6 %) et le doute sur l'utilité réelle des boissons « santé » (45,4 %).</a:t>
+              <a:t>L'annonce « Boissons fermentées sans alcool » atteint 1,53 fois le CTR moyen, le meilleur score du mois.</a:t>
             </a:r>
           </a:p>
         </p:txBody>
@@ -7205,7 +7205,7 @@
                 </a:solidFill>
                 <a:latin typeface="Arial"/>
               </a:rPr>
-              <a:t>→  Mettre en avant le bio, la liste courte d'ingrédients et la fermentation naturelle, avec un bénéfice concret plutôt qu'une promesse santé générale.</a:t>
+              <a:t>→  Mettre l'alternative sans alcool au cœur des accroches : apéritif, repas, pause.</a:t>
             </a:r>
           </a:p>
         </p:txBody>
@@ -7321,7 +7321,7 @@
                 </a:solidFill>
                 <a:latin typeface="Arial"/>
               </a:rPr>
-              <a:t>Se positionner comme l'alternative sans alcool</a:t>
+              <a:t>Mettre en avant le pack de 12 canettes</a:t>
             </a:r>
           </a:p>
         </p:txBody>
@@ -7356,7 +7356,7 @@
                 </a:solidFill>
                 <a:latin typeface="Arial"/>
               </a:rPr>
-              <a:t>Le vin est le premier produit nommé (16,3 %). Les requêtes cherchent des alternatives sans alcool « qui gardent le même goût » : mocktails, Americano sans alcool, digestif sans alcool.</a:t>
+              <a:t>Les packs de 12 canettes de 33 cl dépassent la moyenne (jusqu'à 1,30 fois). Le pack de 6 bouteilles de 75 cl tombe à 0,66 fois.</a:t>
             </a:r>
           </a:p>
         </p:txBody>
@@ -7391,7 +7391,7 @@
                 </a:solidFill>
                 <a:latin typeface="Arial"/>
               </a:rPr>
-              <a:t>→  Présenter Archipel comme la boisson de l'apéritif et du repas sans alcool : « Une alternative pétillante au verre de vin ».</a:t>
+              <a:t>→  Faire de la canette le produit d'appel et garder les grands formats pour la page produit.</a:t>
             </a:r>
           </a:p>
         </p:txBody>
@@ -7507,7 +7507,7 @@
                 </a:solidFill>
                 <a:latin typeface="Arial"/>
               </a:rPr>
-              <a:t>Reprendre de la part de voix face à Ciao Kombucha</a:t>
+              <a:t>Associer le parfum à une sensation</a:t>
             </a:r>
           </a:p>
         </p:txBody>
@@ -7542,7 +7542,7 @@
                 </a:solidFill>
                 <a:latin typeface="Arial"/>
               </a:rPr>
-              <a:t>Archipel recule à 4,8 % de part de voix (−0,8 pt, 6e marque) et à 9,6 % côté ads (−11,1 pts). Ciao Kombucha domine avec 57,1 % et reste n°1 des recommandations spontanées des IA.</a:t>
+              <a:t>Les descriptions qui décrivent le goût (« bouche très fraîche », « notes exotiques ») cliquent mieux que les descriptions courtes. Le kombucha framboise reste sous la moyenne (0,73 fois).</a:t>
             </a:r>
           </a:p>
         </p:txBody>
@@ -7577,7 +7577,7 @@
                 </a:solidFill>
                 <a:latin typeface="Arial"/>
               </a:rPr>
-              <a:t>→  Élargir les topics ciblés pour regagner de la présence publicitaire, et enrichir les contenus de marque pour être cité spontanément.</a:t>
+              <a:t>→  Décrire chaque parfum par la sensation qu'il procure plutôt que par sa recette.</a:t>
             </a:r>
           </a:p>
         </p:txBody>
@@ -7693,7 +7693,7 @@
                 </a:solidFill>
                 <a:latin typeface="Arial"/>
               </a:rPr>
-              <a:t>Capter une demande encore ouverte</a:t>
+              <a:t>Une campagne qui accélère</a:t>
             </a:r>
           </a:p>
         </p:txBody>
@@ -7728,7 +7728,7 @@
                 </a:solidFill>
                 <a:latin typeface="Arial"/>
               </a:rPr>
-              <a:t>Seulement 1,4 % des recherches nomment une marque : l'audience ne connaît pas encore de référence. Sur le mois, la diffusion est multipliée par 2,8 et le CTR passe de 0,41 % à 0,51 %.</a:t>
+              <a:t>Les clics sont multipliés par 3,5 et le CTR passe de 0,41 % à 0,51 %.</a:t>
             </a:r>
           </a:p>
         </p:txBody>
@@ -7763,7 +7763,7 @@
                 </a:solidFill>
                 <a:latin typeface="Arial"/>
               </a:rPr>
-              <a:t>→  Cibler les requêtes génériques (tisane du soir, boisson peu sucrée, pause sans café) avec un parfum associé à chaque occasion.</a:t>
+              <a:t>→  Garder le ciblage actuel et renforcer le message sans alcool à l'approche des fêtes.</a:t>
             </a:r>
           </a:p>
         </p:txBody>

</xml_diff>

<commit_message>
Contrôle ads/flux produits et corrections Archipel, B4B, Bayard
Co-Authored-By: Claude Opus 5.5 <noreply@anthropic.com>
Claude-Session: https://claude.ai/code/session_01BmxtdWjbeRUyPx9e1qVLbT
</commit_message>
<xml_diff>
--- a/rapports/septembre/Archipel_Kombucha_sept2026.pptx
+++ b/rapports/septembre/Archipel_Kombucha_sept2026.pptx
@@ -7321,7 +7321,7 @@
                 </a:solidFill>
                 <a:latin typeface="Arial"/>
               </a:rPr>
-              <a:t>Mettre en avant le pack de 12 canettes</a:t>
+              <a:t>Mettre en avant les packs de 33 cl</a:t>
             </a:r>
           </a:p>
         </p:txBody>
@@ -7356,7 +7356,7 @@
                 </a:solidFill>
                 <a:latin typeface="Arial"/>
               </a:rPr>
-              <a:t>Les packs de 12 canettes de 33 cl dépassent la moyenne (jusqu'à 1,30 fois). Le pack de 6 bouteilles de 75 cl tombe à 0,66 fois.</a:t>
+              <a:t>Les packs de 12 kombuchas de 33 cl dépassent la moyenne (jusqu'à 1,30 fois). Le pack de 6 bouteilles de 75 cl tombe à 0,66 fois.</a:t>
             </a:r>
           </a:p>
         </p:txBody>

</xml_diff>

<commit_message>
Archipel : champ lexical, requêtes et insights alignés sur le catalogue
Co-Authored-By: Claude Opus 5.5 <noreply@anthropic.com>
Claude-Session: https://claude.ai/code/session_01BmxtdWjbeRUyPx9e1qVLbT
</commit_message>
<xml_diff>
--- a/rapports/septembre/Archipel_Kombucha_sept2026.pptx
+++ b/rapports/septembre/Archipel_Kombucha_sept2026.pptx
@@ -5289,7 +5289,7 @@
                 </a:solidFill>
                 <a:latin typeface="Arial"/>
               </a:rPr>
-              <a:t>sans alcool</a:t>
+              <a:t>kombucha bio</a:t>
             </a:r>
             <a:r>
               <a:rPr sz="1800" b="1" i="0">
@@ -5298,7 +5298,7 @@
                 </a:solidFill>
                 <a:latin typeface="Arial"/>
               </a:rPr>
-              <a:t>    vin</a:t>
+              <a:t>   sans alcool</a:t>
             </a:r>
           </a:p>
           <a:p>
@@ -5308,13 +5308,13 @@
               </a:spcAft>
             </a:pPr>
             <a:r>
-              <a:rPr sz="1600" b="1" i="0">
+              <a:rPr sz="1500" b="1" i="0">
                 <a:solidFill>
                   <a:srgbClr val="555B66"/>
                 </a:solidFill>
                 <a:latin typeface="Arial"/>
               </a:rPr>
-              <a:t>café</a:t>
+              <a:t>boissons fermentées</a:t>
             </a:r>
             <a:r>
               <a:rPr sz="1400" b="1" i="0">
@@ -5323,7 +5323,7 @@
                 </a:solidFill>
                 <a:latin typeface="Arial"/>
               </a:rPr>
-              <a:t>    tisane sans caféine</a:t>
+              <a:t>   33 cl</a:t>
             </a:r>
           </a:p>
           <a:p>
@@ -5333,22 +5333,31 @@
               </a:spcAft>
             </a:pPr>
             <a:r>
-              <a:rPr sz="1400" b="1" i="0">
+              <a:rPr sz="1300" b="1" i="0">
                 <a:solidFill>
                   <a:srgbClr val="EE6A2C"/>
                 </a:solidFill>
                 <a:latin typeface="Arial"/>
               </a:rPr>
-              <a:t>mocktail</a:t>
-            </a:r>
-            <a:r>
-              <a:rPr sz="1300" b="0" i="0">
+              <a:t>cassis</a:t>
+            </a:r>
+            <a:r>
+              <a:rPr sz="1200" b="0" i="0">
                 <a:solidFill>
                   <a:srgbClr val="555B66"/>
                 </a:solidFill>
                 <a:latin typeface="Arial"/>
               </a:rPr>
-              <a:t>    eau gazeuse</a:t>
+              <a:t>   figuier</a:t>
+            </a:r>
+            <a:r>
+              <a:rPr sz="1200" b="1" i="0">
+                <a:solidFill>
+                  <a:srgbClr val="111111"/>
+                </a:solidFill>
+                <a:latin typeface="Arial"/>
+              </a:rPr>
+              <a:t>   clémentine</a:t>
             </a:r>
           </a:p>
           <a:p>
@@ -5358,22 +5367,22 @@
               </a:spcAft>
             </a:pPr>
             <a:r>
-              <a:rPr sz="1200" b="1" i="0">
+              <a:rPr sz="1100" b="1" i="0">
                 <a:solidFill>
                   <a:srgbClr val="EE6A2C"/>
                 </a:solidFill>
                 <a:latin typeface="Arial"/>
               </a:rPr>
-              <a:t>lait végétal</a:t>
-            </a:r>
-            <a:r>
-              <a:rPr sz="1200" b="1" i="0">
+              <a:t>pomelo gingembre</a:t>
+            </a:r>
+            <a:r>
+              <a:rPr sz="1100" b="1" i="0">
                 <a:solidFill>
                   <a:srgbClr val="111111"/>
                 </a:solidFill>
                 <a:latin typeface="Arial"/>
               </a:rPr>
-              <a:t>    jus d'orange</a:t>
+              <a:t>   framboise</a:t>
             </a:r>
           </a:p>
           <a:p>
@@ -5389,7 +5398,7 @@
                 </a:solidFill>
                 <a:latin typeface="Arial"/>
               </a:rPr>
-              <a:t>kéfir</a:t>
+              <a:t>apéritif</a:t>
             </a:r>
             <a:r>
               <a:rPr sz="1100" b="0" i="0">
@@ -5398,7 +5407,7 @@
                 </a:solidFill>
                 <a:latin typeface="Arial"/>
               </a:rPr>
-              <a:t>    microbiote</a:t>
+              <a:t>   mocktail</a:t>
             </a:r>
             <a:r>
               <a:rPr sz="1100" b="1" i="0">
@@ -5407,7 +5416,7 @@
                 </a:solidFill>
                 <a:latin typeface="Arial"/>
               </a:rPr>
-              <a:t>    sans pesticides</a:t>
+              <a:t>   pack</a:t>
             </a:r>
           </a:p>
           <a:p>
@@ -5419,11 +5428,11 @@
             <a:r>
               <a:rPr sz="1100" b="1" i="0">
                 <a:solidFill>
-                  <a:srgbClr val="EE6A2C"/>
-                </a:solidFill>
-                <a:latin typeface="Arial"/>
-              </a:rPr>
-              <a:t>eau citronnée</a:t>
+                  <a:srgbClr val="111111"/>
+                </a:solidFill>
+                <a:latin typeface="Arial"/>
+              </a:rPr>
+              <a:t>direct producteur</a:t>
             </a:r>
             <a:r>
               <a:rPr sz="1100" b="0" i="0">
@@ -5432,32 +5441,7 @@
                 </a:solidFill>
                 <a:latin typeface="Arial"/>
               </a:rPr>
-              <a:t>    chia fresca</a:t>
-            </a:r>
-          </a:p>
-          <a:p>
-            <a:pPr algn="l">
-              <a:spcAft>
-                <a:spcPts val="500"/>
-              </a:spcAft>
-            </a:pPr>
-            <a:r>
-              <a:rPr sz="1100" b="1" i="0">
-                <a:solidFill>
-                  <a:srgbClr val="111111"/>
-                </a:solidFill>
-                <a:latin typeface="Arial"/>
-              </a:rPr>
-              <a:t>Ciao Kombucha</a:t>
-            </a:r>
-            <a:r>
-              <a:rPr sz="1100" b="0" i="0">
-                <a:solidFill>
-                  <a:srgbClr val="555B66"/>
-                </a:solidFill>
-                <a:latin typeface="Arial"/>
-              </a:rPr>
-              <a:t>    Karma Kombucha</a:t>
+              <a:t>   fraîcheur</a:t>
             </a:r>
           </a:p>
         </p:txBody>
@@ -5869,52 +5853,43 @@
                 </a:solidFill>
                 <a:latin typeface="Arial"/>
               </a:rPr>
-              <a:t>Quelle tisane sans caféine me recommandes-tu pour le soir ?</a:t>
-            </a:r>
-          </a:p>
-        </p:txBody>
-      </p:sp>
-      <p:sp>
-        <p:nvSpPr>
-          <p:cNvPr id="71" name="Rectangle 70"/>
-          <p:cNvSpPr/>
-          <p:nvPr/>
-        </p:nvSpPr>
-        <p:spPr>
-          <a:xfrm>
-            <a:off x="4437888" y="5364480"/>
-            <a:ext cx="2913888" cy="304800"/>
-          </a:xfrm>
-          <a:prstGeom prst="rect">
-            <a:avLst/>
-          </a:prstGeom>
-          <a:solidFill>
-            <a:srgbClr val="F1EFEA"/>
-          </a:solidFill>
-          <a:ln>
-            <a:noFill/>
-          </a:ln>
-          <a:effectLst/>
-        </p:spPr>
-        <p:style>
-          <a:lnRef idx="1">
-            <a:schemeClr val="accent1"/>
-          </a:lnRef>
-          <a:fillRef idx="3">
-            <a:schemeClr val="accent1"/>
-          </a:fillRef>
-          <a:effectRef idx="2">
-            <a:schemeClr val="accent1"/>
-          </a:effectRef>
-          <a:fontRef idx="minor">
-            <a:schemeClr val="lt1"/>
-          </a:fontRef>
-        </p:style>
-        <p:txBody>
-          <a:bodyPr rtlCol="0" anchor="ctr"/>
-          <a:lstStyle/>
-          <a:p>
-            <a:pPr algn="ctr"/>
+              <a:t>C'est quoi le meilleur mocktail pour les femmes enceintes ?</a:t>
+            </a:r>
+          </a:p>
+        </p:txBody>
+      </p:sp>
+      <p:sp>
+        <p:nvSpPr>
+          <p:cNvPr id="71" name="TextBox 70"/>
+          <p:cNvSpPr txBox="1"/>
+          <p:nvPr/>
+        </p:nvSpPr>
+        <p:spPr>
+          <a:xfrm>
+            <a:off x="8101584" y="3767328"/>
+            <a:ext cx="2926080" cy="152400"/>
+          </a:xfrm>
+          <a:prstGeom prst="rect">
+            <a:avLst/>
+          </a:prstGeom>
+          <a:noFill/>
+        </p:spPr>
+        <p:txBody>
+          <a:bodyPr wrap="square" anchor="t" lIns="0" rIns="0" tIns="0" bIns="0">
+            <a:spAutoFit/>
+          </a:bodyPr>
+          <a:lstStyle/>
+          <a:p>
+            <a:pPr algn="l"/>
+            <a:r>
+              <a:rPr sz="1300" b="1" i="0">
+                <a:solidFill>
+                  <a:srgbClr val="555B66"/>
+                </a:solidFill>
+                <a:latin typeface="Arial"/>
+              </a:rPr>
+              <a:t>CATÉGORIES DE PRODUITS</a:t>
+            </a:r>
           </a:p>
         </p:txBody>
       </p:sp>
@@ -5926,8 +5901,8 @@
         </p:nvSpPr>
         <p:spPr>
           <a:xfrm>
-            <a:off x="4559808" y="5364480"/>
-            <a:ext cx="182880" cy="304800"/>
+            <a:off x="8101584" y="3992880"/>
+            <a:ext cx="2926080" cy="121920"/>
           </a:xfrm>
           <a:prstGeom prst="rect">
             <a:avLst/>
@@ -5935,20 +5910,20 @@
           <a:noFill/>
         </p:spPr>
         <p:txBody>
-          <a:bodyPr wrap="square" anchor="ctr" lIns="0" rIns="0" tIns="0" bIns="0">
+          <a:bodyPr wrap="square" anchor="t" lIns="0" rIns="0" tIns="0" bIns="0">
             <a:spAutoFit/>
           </a:bodyPr>
           <a:lstStyle/>
           <a:p>
             <a:pPr algn="l"/>
             <a:r>
-              <a:rPr sz="900" b="0" i="0">
-                <a:solidFill>
-                  <a:srgbClr val="555B66"/>
-                </a:solidFill>
-                <a:latin typeface="Arial"/>
-              </a:rPr>
-              <a:t>🔍</a:t>
+              <a:rPr sz="1000" b="0" i="1">
+                <a:solidFill>
+                  <a:srgbClr val="8A93A6"/>
+                </a:solidFill>
+                <a:latin typeface="Arial"/>
+              </a:rPr>
+              <a:t>Répartition des requêtes</a:t>
             </a:r>
           </a:p>
         </p:txBody>
@@ -5961,157 +5936,8 @@
         </p:nvSpPr>
         <p:spPr>
           <a:xfrm>
-            <a:off x="4791456" y="5364480"/>
-            <a:ext cx="2499360" cy="304800"/>
-          </a:xfrm>
-          <a:prstGeom prst="rect">
-            <a:avLst/>
-          </a:prstGeom>
-          <a:noFill/>
-        </p:spPr>
-        <p:txBody>
-          <a:bodyPr wrap="square" anchor="ctr" lIns="0" rIns="0" tIns="0" bIns="0">
-            <a:spAutoFit/>
-          </a:bodyPr>
-          <a:lstStyle/>
-          <a:p>
-            <a:pPr algn="l"/>
-            <a:r>
-              <a:rPr sz="900" b="0" i="0">
-                <a:solidFill>
-                  <a:srgbClr val="111111"/>
-                </a:solidFill>
-                <a:latin typeface="Arial"/>
-              </a:rPr>
-              <a:t>Les jus de fruits maison sont-ils vraiment plus sains ?</a:t>
-            </a:r>
-          </a:p>
-        </p:txBody>
-      </p:sp>
-      <p:sp>
-        <p:nvSpPr>
-          <p:cNvPr id="74" name="Rectangle 73"/>
-          <p:cNvSpPr/>
-          <p:nvPr/>
-        </p:nvSpPr>
-        <p:spPr>
-          <a:xfrm>
-            <a:off x="4437888" y="5730240"/>
-            <a:ext cx="2913888" cy="304800"/>
-          </a:xfrm>
-          <a:prstGeom prst="rect">
-            <a:avLst/>
-          </a:prstGeom>
-          <a:solidFill>
-            <a:srgbClr val="F1EFEA"/>
-          </a:solidFill>
-          <a:ln>
-            <a:noFill/>
-          </a:ln>
-          <a:effectLst/>
-        </p:spPr>
-        <p:style>
-          <a:lnRef idx="1">
-            <a:schemeClr val="accent1"/>
-          </a:lnRef>
-          <a:fillRef idx="3">
-            <a:schemeClr val="accent1"/>
-          </a:fillRef>
-          <a:effectRef idx="2">
-            <a:schemeClr val="accent1"/>
-          </a:effectRef>
-          <a:fontRef idx="minor">
-            <a:schemeClr val="lt1"/>
-          </a:fontRef>
-        </p:style>
-        <p:txBody>
-          <a:bodyPr rtlCol="0" anchor="ctr"/>
-          <a:lstStyle/>
-          <a:p>
-            <a:pPr algn="ctr"/>
-          </a:p>
-        </p:txBody>
-      </p:sp>
-      <p:sp>
-        <p:nvSpPr>
-          <p:cNvPr id="75" name="TextBox 74"/>
-          <p:cNvSpPr txBox="1"/>
-          <p:nvPr/>
-        </p:nvSpPr>
-        <p:spPr>
-          <a:xfrm>
-            <a:off x="4559808" y="5730240"/>
-            <a:ext cx="182880" cy="304800"/>
-          </a:xfrm>
-          <a:prstGeom prst="rect">
-            <a:avLst/>
-          </a:prstGeom>
-          <a:noFill/>
-        </p:spPr>
-        <p:txBody>
-          <a:bodyPr wrap="square" anchor="ctr" lIns="0" rIns="0" tIns="0" bIns="0">
-            <a:spAutoFit/>
-          </a:bodyPr>
-          <a:lstStyle/>
-          <a:p>
-            <a:pPr algn="l"/>
-            <a:r>
-              <a:rPr sz="900" b="0" i="0">
-                <a:solidFill>
-                  <a:srgbClr val="555B66"/>
-                </a:solidFill>
-                <a:latin typeface="Arial"/>
-              </a:rPr>
-              <a:t>🔍</a:t>
-            </a:r>
-          </a:p>
-        </p:txBody>
-      </p:sp>
-      <p:sp>
-        <p:nvSpPr>
-          <p:cNvPr id="76" name="TextBox 75"/>
-          <p:cNvSpPr txBox="1"/>
-          <p:nvPr/>
-        </p:nvSpPr>
-        <p:spPr>
-          <a:xfrm>
-            <a:off x="4791456" y="5730240"/>
-            <a:ext cx="2499360" cy="304800"/>
-          </a:xfrm>
-          <a:prstGeom prst="rect">
-            <a:avLst/>
-          </a:prstGeom>
-          <a:noFill/>
-        </p:spPr>
-        <p:txBody>
-          <a:bodyPr wrap="square" anchor="ctr" lIns="0" rIns="0" tIns="0" bIns="0">
-            <a:spAutoFit/>
-          </a:bodyPr>
-          <a:lstStyle/>
-          <a:p>
-            <a:pPr algn="l"/>
-            <a:r>
-              <a:rPr sz="900" b="0" i="0">
-                <a:solidFill>
-                  <a:srgbClr val="111111"/>
-                </a:solidFill>
-                <a:latin typeface="Arial"/>
-              </a:rPr>
-              <a:t>Lait ribot, yaourt ou kéfir : quoi choisir pour le microbiote ?</a:t>
-            </a:r>
-          </a:p>
-        </p:txBody>
-      </p:sp>
-      <p:sp>
-        <p:nvSpPr>
-          <p:cNvPr id="77" name="TextBox 76"/>
-          <p:cNvSpPr txBox="1"/>
-          <p:nvPr/>
-        </p:nvSpPr>
-        <p:spPr>
-          <a:xfrm>
-            <a:off x="8101584" y="3767328"/>
-            <a:ext cx="2926080" cy="152400"/>
+            <a:off x="10607040" y="4175760"/>
+            <a:ext cx="518160" cy="121920"/>
           </a:xfrm>
           <a:prstGeom prst="rect">
             <a:avLst/>
@@ -6124,76 +5950,6 @@
           </a:bodyPr>
           <a:lstStyle/>
           <a:p>
-            <a:pPr algn="l"/>
-            <a:r>
-              <a:rPr sz="1300" b="1" i="0">
-                <a:solidFill>
-                  <a:srgbClr val="555B66"/>
-                </a:solidFill>
-                <a:latin typeface="Arial"/>
-              </a:rPr>
-              <a:t>CATÉGORIES DE PRODUITS</a:t>
-            </a:r>
-          </a:p>
-        </p:txBody>
-      </p:sp>
-      <p:sp>
-        <p:nvSpPr>
-          <p:cNvPr id="78" name="TextBox 77"/>
-          <p:cNvSpPr txBox="1"/>
-          <p:nvPr/>
-        </p:nvSpPr>
-        <p:spPr>
-          <a:xfrm>
-            <a:off x="8101584" y="3992880"/>
-            <a:ext cx="2926080" cy="121920"/>
-          </a:xfrm>
-          <a:prstGeom prst="rect">
-            <a:avLst/>
-          </a:prstGeom>
-          <a:noFill/>
-        </p:spPr>
-        <p:txBody>
-          <a:bodyPr wrap="square" anchor="t" lIns="0" rIns="0" tIns="0" bIns="0">
-            <a:spAutoFit/>
-          </a:bodyPr>
-          <a:lstStyle/>
-          <a:p>
-            <a:pPr algn="l"/>
-            <a:r>
-              <a:rPr sz="1000" b="0" i="1">
-                <a:solidFill>
-                  <a:srgbClr val="8A93A6"/>
-                </a:solidFill>
-                <a:latin typeface="Arial"/>
-              </a:rPr>
-              <a:t>Répartition des requêtes</a:t>
-            </a:r>
-          </a:p>
-        </p:txBody>
-      </p:sp>
-      <p:sp>
-        <p:nvSpPr>
-          <p:cNvPr id="79" name="TextBox 78"/>
-          <p:cNvSpPr txBox="1"/>
-          <p:nvPr/>
-        </p:nvSpPr>
-        <p:spPr>
-          <a:xfrm>
-            <a:off x="10607040" y="4175760"/>
-            <a:ext cx="518160" cy="121920"/>
-          </a:xfrm>
-          <a:prstGeom prst="rect">
-            <a:avLst/>
-          </a:prstGeom>
-          <a:noFill/>
-        </p:spPr>
-        <p:txBody>
-          <a:bodyPr wrap="square" anchor="t" lIns="0" rIns="0" tIns="0" bIns="0">
-            <a:spAutoFit/>
-          </a:bodyPr>
-          <a:lstStyle/>
-          <a:p>
             <a:pPr algn="r"/>
             <a:r>
               <a:rPr sz="1100" b="1" i="0">
@@ -6209,7 +5965,7 @@
       </p:sp>
       <p:sp>
         <p:nvSpPr>
-          <p:cNvPr id="80" name="Rectangle 79"/>
+          <p:cNvPr id="74" name="Rectangle 73"/>
           <p:cNvSpPr/>
           <p:nvPr/>
         </p:nvSpPr>
@@ -6253,7 +6009,7 @@
       </p:sp>
       <p:sp>
         <p:nvSpPr>
-          <p:cNvPr id="81" name="TextBox 80"/>
+          <p:cNvPr id="75" name="TextBox 74"/>
           <p:cNvSpPr txBox="1"/>
           <p:nvPr/>
         </p:nvSpPr>
@@ -6288,7 +6044,7 @@
       </p:sp>
       <p:sp>
         <p:nvSpPr>
-          <p:cNvPr id="82" name="Rectangle 81"/>
+          <p:cNvPr id="76" name="Rectangle 75"/>
           <p:cNvSpPr/>
           <p:nvPr/>
         </p:nvSpPr>
@@ -6332,7 +6088,7 @@
       </p:sp>
       <p:sp>
         <p:nvSpPr>
-          <p:cNvPr id="83" name="TextBox 82"/>
+          <p:cNvPr id="77" name="TextBox 76"/>
           <p:cNvSpPr txBox="1"/>
           <p:nvPr/>
         </p:nvSpPr>
@@ -6367,7 +6123,7 @@
       </p:sp>
       <p:sp>
         <p:nvSpPr>
-          <p:cNvPr id="84" name="Rectangle 83"/>
+          <p:cNvPr id="78" name="Rectangle 77"/>
           <p:cNvSpPr/>
           <p:nvPr/>
         </p:nvSpPr>
@@ -6411,7 +6167,7 @@
       </p:sp>
       <p:sp>
         <p:nvSpPr>
-          <p:cNvPr id="85" name="TextBox 84"/>
+          <p:cNvPr id="79" name="TextBox 78"/>
           <p:cNvSpPr txBox="1"/>
           <p:nvPr/>
         </p:nvSpPr>
@@ -6446,7 +6202,7 @@
       </p:sp>
       <p:sp>
         <p:nvSpPr>
-          <p:cNvPr id="86" name="Rectangle 85"/>
+          <p:cNvPr id="80" name="Rectangle 79"/>
           <p:cNvSpPr/>
           <p:nvPr/>
         </p:nvSpPr>
@@ -6490,7 +6246,7 @@
       </p:sp>
       <p:sp>
         <p:nvSpPr>
-          <p:cNvPr id="87" name="TextBox 86"/>
+          <p:cNvPr id="81" name="TextBox 80"/>
           <p:cNvSpPr txBox="1"/>
           <p:nvPr/>
         </p:nvSpPr>
@@ -6525,7 +6281,7 @@
       </p:sp>
       <p:sp>
         <p:nvSpPr>
-          <p:cNvPr id="88" name="Rectangle 87"/>
+          <p:cNvPr id="82" name="Rectangle 81"/>
           <p:cNvSpPr/>
           <p:nvPr/>
         </p:nvSpPr>
@@ -6569,7 +6325,7 @@
       </p:sp>
       <p:sp>
         <p:nvSpPr>
-          <p:cNvPr id="89" name="TextBox 88"/>
+          <p:cNvPr id="83" name="TextBox 82"/>
           <p:cNvSpPr txBox="1"/>
           <p:nvPr/>
         </p:nvSpPr>
@@ -6604,7 +6360,7 @@
       </p:sp>
       <p:sp>
         <p:nvSpPr>
-          <p:cNvPr id="90" name="Rectangle 89"/>
+          <p:cNvPr id="84" name="Rectangle 83"/>
           <p:cNvSpPr/>
           <p:nvPr/>
         </p:nvSpPr>
@@ -6648,7 +6404,7 @@
       </p:sp>
       <p:sp>
         <p:nvSpPr>
-          <p:cNvPr id="91" name="Rectangle 90"/>
+          <p:cNvPr id="85" name="Rectangle 84"/>
           <p:cNvSpPr/>
           <p:nvPr/>
         </p:nvSpPr>
@@ -6692,7 +6448,7 @@
       </p:sp>
       <p:sp>
         <p:nvSpPr>
-          <p:cNvPr id="92" name="Rectangle 91"/>
+          <p:cNvPr id="86" name="Rectangle 85"/>
           <p:cNvSpPr/>
           <p:nvPr/>
         </p:nvSpPr>
@@ -7321,7 +7077,7 @@
                 </a:solidFill>
                 <a:latin typeface="Arial"/>
               </a:rPr>
-              <a:t>Mettre en avant les packs de 33 cl</a:t>
+              <a:t>Mettre en avant les formats 33 cl</a:t>
             </a:r>
           </a:p>
         </p:txBody>
@@ -7391,7 +7147,7 @@
                 </a:solidFill>
                 <a:latin typeface="Arial"/>
               </a:rPr>
-              <a:t>→  Faire de la canette le produit d'appel et garder les grands formats pour la page produit.</a:t>
+              <a:t>→  Faire des formats 33 cl le produit d'appel et garder les 75 cl pour la page produit.</a:t>
             </a:r>
           </a:p>
         </p:txBody>
@@ -7507,7 +7263,7 @@
                 </a:solidFill>
                 <a:latin typeface="Arial"/>
               </a:rPr>
-              <a:t>Associer le parfum à une sensation</a:t>
+              <a:t>Mettre le cassis et le pomelo gingembre en avant</a:t>
             </a:r>
           </a:p>
         </p:txBody>
@@ -7542,7 +7298,7 @@
                 </a:solidFill>
                 <a:latin typeface="Arial"/>
               </a:rPr>
-              <a:t>Les descriptions qui décrivent le goût (« bouche très fraîche », « notes exotiques ») cliquent mieux que les descriptions courtes. Le kombucha framboise reste sous la moyenne (0,73 fois).</a:t>
+              <a:t>Les annonces pomelo gingembre (1,23 fois le CTR moyen) et cassis (1,15 fois) font mieux que la moyenne. Framboise, figuier et clémentine restent juste en dessous (0,93 fois).</a:t>
             </a:r>
           </a:p>
         </p:txBody>
@@ -7577,7 +7333,7 @@
                 </a:solidFill>
                 <a:latin typeface="Arial"/>
               </a:rPr>
-              <a:t>→  Décrire chaque parfum par la sensation qu'il procure plutôt que par sa recette.</a:t>
+              <a:t>→  Donner plus de visibilité au cassis et au pomelo gingembre.</a:t>
             </a:r>
           </a:p>
         </p:txBody>

</xml_diff>

<commit_message>
Archipel : retrait d'une requête non sourcée
Co-Authored-By: Claude Opus 5.5 <noreply@anthropic.com>
Claude-Session: https://claude.ai/code/session_01BmxtdWjbeRUyPx9e1qVLbT
</commit_message>
<xml_diff>
--- a/rapports/septembre/Archipel_Kombucha_sept2026.pptx
+++ b/rapports/septembre/Archipel_Kombucha_sept2026.pptx
@@ -5746,121 +5746,7 @@
       </p:sp>
       <p:sp>
         <p:nvSpPr>
-          <p:cNvPr id="68" name="Rectangle 67"/>
-          <p:cNvSpPr/>
-          <p:nvPr/>
-        </p:nvSpPr>
-        <p:spPr>
-          <a:xfrm>
-            <a:off x="4437888" y="4998720"/>
-            <a:ext cx="2913888" cy="304800"/>
-          </a:xfrm>
-          <a:prstGeom prst="rect">
-            <a:avLst/>
-          </a:prstGeom>
-          <a:solidFill>
-            <a:srgbClr val="F1EFEA"/>
-          </a:solidFill>
-          <a:ln>
-            <a:noFill/>
-          </a:ln>
-          <a:effectLst/>
-        </p:spPr>
-        <p:style>
-          <a:lnRef idx="1">
-            <a:schemeClr val="accent1"/>
-          </a:lnRef>
-          <a:fillRef idx="3">
-            <a:schemeClr val="accent1"/>
-          </a:fillRef>
-          <a:effectRef idx="2">
-            <a:schemeClr val="accent1"/>
-          </a:effectRef>
-          <a:fontRef idx="minor">
-            <a:schemeClr val="lt1"/>
-          </a:fontRef>
-        </p:style>
-        <p:txBody>
-          <a:bodyPr rtlCol="0" anchor="ctr"/>
-          <a:lstStyle/>
-          <a:p>
-            <a:pPr algn="ctr"/>
-          </a:p>
-        </p:txBody>
-      </p:sp>
-      <p:sp>
-        <p:nvSpPr>
-          <p:cNvPr id="69" name="TextBox 68"/>
-          <p:cNvSpPr txBox="1"/>
-          <p:nvPr/>
-        </p:nvSpPr>
-        <p:spPr>
-          <a:xfrm>
-            <a:off x="4559808" y="4998720"/>
-            <a:ext cx="182880" cy="304800"/>
-          </a:xfrm>
-          <a:prstGeom prst="rect">
-            <a:avLst/>
-          </a:prstGeom>
-          <a:noFill/>
-        </p:spPr>
-        <p:txBody>
-          <a:bodyPr wrap="square" anchor="ctr" lIns="0" rIns="0" tIns="0" bIns="0">
-            <a:spAutoFit/>
-          </a:bodyPr>
-          <a:lstStyle/>
-          <a:p>
-            <a:pPr algn="l"/>
-            <a:r>
-              <a:rPr sz="900" b="0" i="0">
-                <a:solidFill>
-                  <a:srgbClr val="555B66"/>
-                </a:solidFill>
-                <a:latin typeface="Arial"/>
-              </a:rPr>
-              <a:t>🔍</a:t>
-            </a:r>
-          </a:p>
-        </p:txBody>
-      </p:sp>
-      <p:sp>
-        <p:nvSpPr>
-          <p:cNvPr id="70" name="TextBox 69"/>
-          <p:cNvSpPr txBox="1"/>
-          <p:nvPr/>
-        </p:nvSpPr>
-        <p:spPr>
-          <a:xfrm>
-            <a:off x="4791456" y="4998720"/>
-            <a:ext cx="2499360" cy="304800"/>
-          </a:xfrm>
-          <a:prstGeom prst="rect">
-            <a:avLst/>
-          </a:prstGeom>
-          <a:noFill/>
-        </p:spPr>
-        <p:txBody>
-          <a:bodyPr wrap="square" anchor="ctr" lIns="0" rIns="0" tIns="0" bIns="0">
-            <a:spAutoFit/>
-          </a:bodyPr>
-          <a:lstStyle/>
-          <a:p>
-            <a:pPr algn="l"/>
-            <a:r>
-              <a:rPr sz="900" b="0" i="0">
-                <a:solidFill>
-                  <a:srgbClr val="111111"/>
-                </a:solidFill>
-                <a:latin typeface="Arial"/>
-              </a:rPr>
-              <a:t>C'est quoi le meilleur mocktail pour les femmes enceintes ?</a:t>
-            </a:r>
-          </a:p>
-        </p:txBody>
-      </p:sp>
-      <p:sp>
-        <p:nvSpPr>
-          <p:cNvPr id="71" name="TextBox 70"/>
+          <p:cNvPr id="68" name="TextBox 67"/>
           <p:cNvSpPr txBox="1"/>
           <p:nvPr/>
         </p:nvSpPr>
@@ -5895,7 +5781,7 @@
       </p:sp>
       <p:sp>
         <p:nvSpPr>
-          <p:cNvPr id="72" name="TextBox 71"/>
+          <p:cNvPr id="69" name="TextBox 68"/>
           <p:cNvSpPr txBox="1"/>
           <p:nvPr/>
         </p:nvSpPr>
@@ -5930,7 +5816,7 @@
       </p:sp>
       <p:sp>
         <p:nvSpPr>
-          <p:cNvPr id="73" name="TextBox 72"/>
+          <p:cNvPr id="70" name="TextBox 69"/>
           <p:cNvSpPr txBox="1"/>
           <p:nvPr/>
         </p:nvSpPr>
@@ -5965,7 +5851,7 @@
       </p:sp>
       <p:sp>
         <p:nvSpPr>
-          <p:cNvPr id="74" name="Rectangle 73"/>
+          <p:cNvPr id="71" name="Rectangle 70"/>
           <p:cNvSpPr/>
           <p:nvPr/>
         </p:nvSpPr>
@@ -6009,7 +5895,7 @@
       </p:sp>
       <p:sp>
         <p:nvSpPr>
-          <p:cNvPr id="75" name="TextBox 74"/>
+          <p:cNvPr id="72" name="TextBox 71"/>
           <p:cNvSpPr txBox="1"/>
           <p:nvPr/>
         </p:nvSpPr>
@@ -6044,7 +5930,7 @@
       </p:sp>
       <p:sp>
         <p:nvSpPr>
-          <p:cNvPr id="76" name="Rectangle 75"/>
+          <p:cNvPr id="73" name="Rectangle 72"/>
           <p:cNvSpPr/>
           <p:nvPr/>
         </p:nvSpPr>
@@ -6088,7 +5974,7 @@
       </p:sp>
       <p:sp>
         <p:nvSpPr>
-          <p:cNvPr id="77" name="TextBox 76"/>
+          <p:cNvPr id="74" name="TextBox 73"/>
           <p:cNvSpPr txBox="1"/>
           <p:nvPr/>
         </p:nvSpPr>
@@ -6123,7 +6009,7 @@
       </p:sp>
       <p:sp>
         <p:nvSpPr>
-          <p:cNvPr id="78" name="Rectangle 77"/>
+          <p:cNvPr id="75" name="Rectangle 74"/>
           <p:cNvSpPr/>
           <p:nvPr/>
         </p:nvSpPr>
@@ -6167,7 +6053,7 @@
       </p:sp>
       <p:sp>
         <p:nvSpPr>
-          <p:cNvPr id="79" name="TextBox 78"/>
+          <p:cNvPr id="76" name="TextBox 75"/>
           <p:cNvSpPr txBox="1"/>
           <p:nvPr/>
         </p:nvSpPr>
@@ -6202,7 +6088,7 @@
       </p:sp>
       <p:sp>
         <p:nvSpPr>
-          <p:cNvPr id="80" name="Rectangle 79"/>
+          <p:cNvPr id="77" name="Rectangle 76"/>
           <p:cNvSpPr/>
           <p:nvPr/>
         </p:nvSpPr>
@@ -6246,7 +6132,7 @@
       </p:sp>
       <p:sp>
         <p:nvSpPr>
-          <p:cNvPr id="81" name="TextBox 80"/>
+          <p:cNvPr id="78" name="TextBox 77"/>
           <p:cNvSpPr txBox="1"/>
           <p:nvPr/>
         </p:nvSpPr>
@@ -6281,7 +6167,7 @@
       </p:sp>
       <p:sp>
         <p:nvSpPr>
-          <p:cNvPr id="82" name="Rectangle 81"/>
+          <p:cNvPr id="79" name="Rectangle 78"/>
           <p:cNvSpPr/>
           <p:nvPr/>
         </p:nvSpPr>
@@ -6325,7 +6211,7 @@
       </p:sp>
       <p:sp>
         <p:nvSpPr>
-          <p:cNvPr id="83" name="TextBox 82"/>
+          <p:cNvPr id="80" name="TextBox 79"/>
           <p:cNvSpPr txBox="1"/>
           <p:nvPr/>
         </p:nvSpPr>
@@ -6360,7 +6246,7 @@
       </p:sp>
       <p:sp>
         <p:nvSpPr>
-          <p:cNvPr id="84" name="Rectangle 83"/>
+          <p:cNvPr id="81" name="Rectangle 80"/>
           <p:cNvSpPr/>
           <p:nvPr/>
         </p:nvSpPr>
@@ -6404,7 +6290,7 @@
       </p:sp>
       <p:sp>
         <p:nvSpPr>
-          <p:cNvPr id="85" name="Rectangle 84"/>
+          <p:cNvPr id="82" name="Rectangle 81"/>
           <p:cNvSpPr/>
           <p:nvPr/>
         </p:nvSpPr>
@@ -6448,7 +6334,7 @@
       </p:sp>
       <p:sp>
         <p:nvSpPr>
-          <p:cNvPr id="86" name="Rectangle 85"/>
+          <p:cNvPr id="83" name="Rectangle 82"/>
           <p:cNvSpPr/>
           <p:nvPr/>
         </p:nvSpPr>

</xml_diff>